<commit_message>
fixes some minor issues with testing content
</commit_message>
<xml_diff>
--- a/Python/Lesson 11 - Testing/Lesson 11 - Testing.pptx
+++ b/Python/Lesson 11 - Testing/Lesson 11 - Testing.pptx
@@ -5,7 +5,7 @@
     <p:sldMasterId id="2147483673" r:id="rId1"/>
   </p:sldMasterIdLst>
   <p:notesMasterIdLst>
-    <p:notesMasterId r:id="rId27"/>
+    <p:notesMasterId r:id="rId28"/>
   </p:notesMasterIdLst>
   <p:sldIdLst>
     <p:sldId id="321" r:id="rId2"/>
@@ -25,14 +25,15 @@
     <p:sldId id="331" r:id="rId16"/>
     <p:sldId id="341" r:id="rId17"/>
     <p:sldId id="340" r:id="rId18"/>
-    <p:sldId id="333" r:id="rId19"/>
-    <p:sldId id="343" r:id="rId20"/>
-    <p:sldId id="344" r:id="rId21"/>
-    <p:sldId id="345" r:id="rId22"/>
-    <p:sldId id="329" r:id="rId23"/>
-    <p:sldId id="346" r:id="rId24"/>
-    <p:sldId id="347" r:id="rId25"/>
-    <p:sldId id="313" r:id="rId26"/>
+    <p:sldId id="348" r:id="rId19"/>
+    <p:sldId id="333" r:id="rId20"/>
+    <p:sldId id="343" r:id="rId21"/>
+    <p:sldId id="344" r:id="rId22"/>
+    <p:sldId id="345" r:id="rId23"/>
+    <p:sldId id="329" r:id="rId24"/>
+    <p:sldId id="346" r:id="rId25"/>
+    <p:sldId id="347" r:id="rId26"/>
+    <p:sldId id="313" r:id="rId27"/>
   </p:sldIdLst>
   <p:sldSz cx="9144000" cy="5143500" type="screen16x9"/>
   <p:notesSz cx="6858000" cy="9144000"/>
@@ -1184,7 +1185,7 @@
           <a:p>
             <a:fld id="{7A3E0868-4E26-4CDC-8A56-D70E2D8B12FE}" type="datetime3">
               <a:rPr lang="en-US" smtClean="0"/>
-              <a:t>18 June 2026</a:t>
+              <a:t>23 June 2026</a:t>
             </a:fld>
             <a:endParaRPr lang="en-US"/>
           </a:p>
@@ -3763,7 +3764,7 @@
           <a:p>
             <a:fld id="{A7B8021B-6105-4216-96FC-94348F216D0E}" type="datetime3">
               <a:rPr lang="en-US" smtClean="0"/>
-              <a:t>18 June 2026</a:t>
+              <a:t>23 June 2026</a:t>
             </a:fld>
             <a:endParaRPr lang="en-US"/>
           </a:p>
@@ -5484,7 +5485,7 @@
           <a:p>
             <a:fld id="{5D27CFAB-73E6-44A8-B862-B3306344E3F2}" type="datetime3">
               <a:rPr lang="en-US" smtClean="0"/>
-              <a:t>18 June 2026</a:t>
+              <a:t>23 June 2026</a:t>
             </a:fld>
             <a:endParaRPr lang="en-US"/>
           </a:p>
@@ -7298,7 +7299,7 @@
           <a:p>
             <a:fld id="{A9B2E784-A5F5-4301-881B-94AC8DBF9DED}" type="datetime3">
               <a:rPr lang="en-US" smtClean="0"/>
-              <a:t>18 June 2026</a:t>
+              <a:t>23 June 2026</a:t>
             </a:fld>
             <a:endParaRPr lang="en-US"/>
           </a:p>
@@ -7480,7 +7481,7 @@
           <a:p>
             <a:fld id="{18EAB3A5-9E92-4BB9-8F22-9632B4FBEDBA}" type="datetime3">
               <a:rPr lang="en-US" smtClean="0"/>
-              <a:t>18 June 2026</a:t>
+              <a:t>23 June 2026</a:t>
             </a:fld>
             <a:endParaRPr lang="en-US"/>
           </a:p>
@@ -7710,7 +7711,7 @@
           <a:p>
             <a:fld id="{40923810-5FB2-48C9-96CA-1DE2C4773142}" type="datetime3">
               <a:rPr lang="en-US" smtClean="0"/>
-              <a:t>18 June 2026</a:t>
+              <a:t>23 June 2026</a:t>
             </a:fld>
             <a:endParaRPr lang="en-US"/>
           </a:p>
@@ -8009,7 +8010,7 @@
           <a:p>
             <a:fld id="{E50EFF4B-86EB-42FB-93EA-7D8F9CB2466F}" type="datetime3">
               <a:rPr lang="en-US" smtClean="0"/>
-              <a:t>18 June 2026</a:t>
+              <a:t>23 June 2026</a:t>
             </a:fld>
             <a:endParaRPr lang="en-US"/>
           </a:p>
@@ -8639,7 +8640,7 @@
           <a:p>
             <a:fld id="{FB14FC24-E041-45E9-9A72-E5755A86890F}" type="datetime3">
               <a:rPr lang="en-US" smtClean="0"/>
-              <a:t>18 June 2026</a:t>
+              <a:t>23 June 2026</a:t>
             </a:fld>
             <a:endParaRPr lang="en-US"/>
           </a:p>
@@ -9526,7 +9527,7 @@
           <a:p>
             <a:fld id="{98A19125-94A7-4474-858C-FD9C4ABE9DDA}" type="datetime3">
               <a:rPr lang="en-US" smtClean="0"/>
-              <a:t>18 June 2026</a:t>
+              <a:t>23 June 2026</a:t>
             </a:fld>
             <a:endParaRPr lang="en-US"/>
           </a:p>
@@ -10665,7 +10666,7 @@
           <a:p>
             <a:fld id="{3BA0343D-C8D8-43CE-BB79-50DEA219DB07}" type="datetime3">
               <a:rPr lang="en-US" smtClean="0"/>
-              <a:t>18 June 2026</a:t>
+              <a:t>23 June 2026</a:t>
             </a:fld>
             <a:endParaRPr lang="en-US"/>
           </a:p>
@@ -10957,7 +10958,7 @@
           <a:p>
             <a:fld id="{453BD212-0B9F-4987-965F-AC83B2FC354F}" type="datetime3">
               <a:rPr lang="en-US" smtClean="0"/>
-              <a:t>18 June 2026</a:t>
+              <a:t>23 June 2026</a:t>
             </a:fld>
             <a:endParaRPr lang="en-US"/>
           </a:p>
@@ -11202,7 +11203,7 @@
           <a:p>
             <a:fld id="{6DDC931E-8CBE-4A3F-A034-9B6122C6DCDB}" type="datetime3">
               <a:rPr lang="en-US" smtClean="0"/>
-              <a:t>18 June 2026</a:t>
+              <a:t>23 June 2026</a:t>
             </a:fld>
             <a:endParaRPr lang="en-US"/>
           </a:p>
@@ -12980,7 +12981,7 @@
           <a:p>
             <a:fld id="{220AF9C2-5E8A-4308-AE6B-CA9B65007D0E}" type="datetime3">
               <a:rPr lang="en-US" smtClean="0"/>
-              <a:t>18 June 2026</a:t>
+              <a:t>23 June 2026</a:t>
             </a:fld>
             <a:endParaRPr lang="en-US"/>
           </a:p>
@@ -13296,7 +13297,7 @@
           <a:p>
             <a:fld id="{FF31E861-D2AF-431D-860B-DCF67C218052}" type="datetime3">
               <a:rPr lang="en-US" smtClean="0"/>
-              <a:t>18 June 2026</a:t>
+              <a:t>23 June 2026</a:t>
             </a:fld>
             <a:endParaRPr lang="en-US"/>
           </a:p>
@@ -13578,7 +13579,7 @@
           <a:p>
             <a:fld id="{D1DA25B2-AAF1-4C1F-AA38-12D5BFA7D4C8}" type="datetime3">
               <a:rPr lang="en-US" smtClean="0"/>
-              <a:t>18 June 2026</a:t>
+              <a:t>23 June 2026</a:t>
             </a:fld>
             <a:endParaRPr lang="en-US"/>
           </a:p>
@@ -13860,7 +13861,7 @@
           <a:p>
             <a:fld id="{A25C0F39-45D0-48E9-90B3-7FE8FCE561C8}" type="datetime3">
               <a:rPr lang="en-US" smtClean="0"/>
-              <a:t>18 June 2026</a:t>
+              <a:t>23 June 2026</a:t>
             </a:fld>
             <a:endParaRPr lang="en-US"/>
           </a:p>
@@ -14370,7 +14371,7 @@
           <a:p>
             <a:fld id="{9BAF1A3D-92FA-4F24-9781-74AFA516A230}" type="datetime3">
               <a:rPr lang="en-US" smtClean="0"/>
-              <a:t>18 June 2026</a:t>
+              <a:t>23 June 2026</a:t>
             </a:fld>
             <a:endParaRPr lang="en-US"/>
           </a:p>
@@ -14497,7 +14498,7 @@
           <a:p>
             <a:fld id="{5719C672-856D-4617-A693-8FE15749A9B7}" type="datetime3">
               <a:rPr lang="en-US" smtClean="0"/>
-              <a:t>18 June 2026</a:t>
+              <a:t>23 June 2026</a:t>
             </a:fld>
             <a:endParaRPr lang="en-US"/>
           </a:p>
@@ -14632,7 +14633,7 @@
           <a:p>
             <a:fld id="{5F6C764D-A39E-4C03-B161-E0BC66E8883B}" type="datetime3">
               <a:rPr lang="en-US" smtClean="0"/>
-              <a:t>18 June 2026</a:t>
+              <a:t>23 June 2026</a:t>
             </a:fld>
             <a:endParaRPr lang="en-US"/>
           </a:p>
@@ -14874,7 +14875,7 @@
           <a:p>
             <a:fld id="{6E3E33F9-20B7-4995-BE7D-165DBB597850}" type="datetime3">
               <a:rPr lang="en-US" smtClean="0"/>
-              <a:t>18 June 2026</a:t>
+              <a:t>23 June 2026</a:t>
             </a:fld>
             <a:endParaRPr lang="en-US"/>
           </a:p>
@@ -14987,7 +14988,7 @@
           <a:p>
             <a:fld id="{CD41C263-3501-4369-A962-62B6BF915CDE}" type="datetime3">
               <a:rPr lang="en-US" smtClean="0"/>
-              <a:t>18 June 2026</a:t>
+              <a:t>23 June 2026</a:t>
             </a:fld>
             <a:endParaRPr lang="en-US"/>
           </a:p>
@@ -15393,7 +15394,7 @@
           <a:p>
             <a:fld id="{B06F3EBE-B2E8-4992-9F00-9E4B44F057C0}" type="datetime3">
               <a:rPr lang="en-US" smtClean="0"/>
-              <a:t>18 June 2026</a:t>
+              <a:t>23 June 2026</a:t>
             </a:fld>
             <a:endParaRPr lang="en-US"/>
           </a:p>
@@ -15525,7 +15526,7 @@
           <a:p>
             <a:fld id="{D41656AB-D2E1-472E-8B95-0DF5C6E1D623}" type="datetime3">
               <a:rPr lang="en-US" smtClean="0"/>
-              <a:t>18 June 2026</a:t>
+              <a:t>23 June 2026</a:t>
             </a:fld>
             <a:endParaRPr lang="en-US"/>
           </a:p>
@@ -19675,7 +19676,7 @@
           <a:p>
             <a:fld id="{AD622D1A-DF83-41A8-85FF-04D90BF831D3}" type="datetime3">
               <a:rPr lang="en-US" smtClean="0"/>
-              <a:t>18 June 2026</a:t>
+              <a:t>23 June 2026</a:t>
             </a:fld>
             <a:endParaRPr lang="en-US"/>
           </a:p>
@@ -19931,7 +19932,7 @@
           <a:p>
             <a:fld id="{334F72C3-CDF3-44A8-B602-1649B1728485}" type="datetime3">
               <a:rPr lang="en-US" smtClean="0"/>
-              <a:t>18 June 2026</a:t>
+              <a:t>23 June 2026</a:t>
             </a:fld>
             <a:endParaRPr lang="en-US"/>
           </a:p>
@@ -20247,7 +20248,7 @@
           <a:p>
             <a:fld id="{1E0132BA-B5E7-4FFD-AF6C-169169D47D4A}" type="datetime3">
               <a:rPr lang="en-US" smtClean="0"/>
-              <a:t>18 June 2026</a:t>
+              <a:t>23 June 2026</a:t>
             </a:fld>
             <a:endParaRPr lang="en-US"/>
           </a:p>
@@ -20740,7 +20741,7 @@
           <a:p>
             <a:fld id="{81A30091-1C2A-4151-8D3C-D1E47A72615F}" type="datetime3">
               <a:rPr lang="en-US" smtClean="0"/>
-              <a:t>18 June 2026</a:t>
+              <a:t>23 June 2026</a:t>
             </a:fld>
             <a:endParaRPr lang="en-US"/>
           </a:p>
@@ -21401,7 +21402,7 @@
           <a:p>
             <a:fld id="{35D703CE-07B4-4C05-A488-B4566700621F}" type="datetime3">
               <a:rPr lang="en-US" smtClean="0"/>
-              <a:t>18 June 2026</a:t>
+              <a:t>23 June 2026</a:t>
             </a:fld>
             <a:endParaRPr lang="en-US"/>
           </a:p>
@@ -22471,7 +22472,7 @@
           <a:p>
             <a:fld id="{694BD61C-20BA-43AF-A21F-1DAFB3200099}" type="datetime3">
               <a:rPr lang="en-US" smtClean="0"/>
-              <a:t>18 June 2026</a:t>
+              <a:t>23 June 2026</a:t>
             </a:fld>
             <a:endParaRPr lang="en-US"/>
           </a:p>
@@ -22958,7 +22959,7 @@
           <a:p>
             <a:fld id="{CABCB1B0-B6E5-4DD1-BB55-95C076D6C0C8}" type="datetime3">
               <a:rPr lang="en-US" smtClean="0"/>
-              <a:t>18 June 2026</a:t>
+              <a:t>23 June 2026</a:t>
             </a:fld>
             <a:endParaRPr lang="en-US"/>
           </a:p>
@@ -25090,7 +25091,7 @@
           <a:p>
             <a:fld id="{334F72C3-CDF3-44A8-B602-1649B1728485}" type="datetime3">
               <a:rPr lang="en-US" smtClean="0"/>
-              <a:t>18 June 2026</a:t>
+              <a:t>23 June 2026</a:t>
             </a:fld>
             <a:endParaRPr lang="en-US"/>
           </a:p>
@@ -26318,7 +26319,7 @@
           <a:p>
             <a:fld id="{334F72C3-CDF3-44A8-B602-1649B1728485}" type="datetime3">
               <a:rPr lang="en-US" smtClean="0"/>
-              <a:t>18 June 2026</a:t>
+              <a:t>23 June 2026</a:t>
             </a:fld>
             <a:endParaRPr lang="en-US"/>
           </a:p>
@@ -26632,7 +26633,7 @@
           <a:p>
             <a:fld id="{334F72C3-CDF3-44A8-B602-1649B1728485}" type="datetime3">
               <a:rPr lang="en-US" smtClean="0"/>
-              <a:t>18 June 2026</a:t>
+              <a:t>23 June 2026</a:t>
             </a:fld>
             <a:endParaRPr lang="en-US"/>
           </a:p>
@@ -26926,7 +26927,7 @@
           <a:p>
             <a:r>
               <a:rPr lang="en-US" dirty="0"/>
-              <a:t>Are we covering every branch?</a:t>
+              <a:t>Are we covering every path?</a:t>
             </a:r>
           </a:p>
           <a:p>
@@ -26942,6 +26943,12 @@
             </a:r>
           </a:p>
           <a:p>
+            <a:r>
+              <a:rPr lang="en-US" dirty="0"/>
+              <a:t>Generally ~80%, domain dependent</a:t>
+            </a:r>
+          </a:p>
+          <a:p>
             <a:endParaRPr lang="en-US" dirty="0"/>
           </a:p>
         </p:txBody>
@@ -26969,7 +26976,7 @@
           <a:p>
             <a:fld id="{AD622D1A-DF83-41A8-85FF-04D90BF831D3}" type="datetime3">
               <a:rPr lang="en-US" smtClean="0"/>
-              <a:t>18 June 2026</a:t>
+              <a:t>23 June 2026</a:t>
             </a:fld>
             <a:endParaRPr lang="en-US"/>
           </a:p>
@@ -27005,6 +27012,37 @@
           </a:p>
         </p:txBody>
       </p:sp>
+      <p:pic>
+        <p:nvPicPr>
+          <p:cNvPr id="6" name="Picture 5" descr="What Is Statement Coverage And Branch Coverage In Software Testing at ...">
+            <a:extLst>
+              <a:ext uri="{FF2B5EF4-FFF2-40B4-BE49-F238E27FC236}">
+                <a16:creationId xmlns:a16="http://schemas.microsoft.com/office/drawing/2014/main" id="{03056A6A-6572-3F99-4899-EE9D05508D30}"/>
+              </a:ext>
+            </a:extLst>
+          </p:cNvPr>
+          <p:cNvPicPr>
+            <a:picLocks noChangeAspect="1"/>
+          </p:cNvPicPr>
+          <p:nvPr/>
+        </p:nvPicPr>
+        <p:blipFill>
+          <a:blip r:embed="rId2"/>
+          <a:srcRect r="40450"/>
+          <a:stretch>
+            <a:fillRect/>
+          </a:stretch>
+        </p:blipFill>
+        <p:spPr>
+          <a:xfrm>
+            <a:off x="4875054" y="822294"/>
+            <a:ext cx="4083932" cy="3857625"/>
+          </a:xfrm>
+          <a:prstGeom prst="rect">
+            <a:avLst/>
+          </a:prstGeom>
+        </p:spPr>
+      </p:pic>
     </p:spTree>
     <p:extLst>
       <p:ext uri="{BB962C8B-B14F-4D97-AF65-F5344CB8AC3E}">
@@ -27072,6 +27110,55 @@
                       </p:childTnLst>
                     </p:cTn>
                   </p:par>
+                  <p:par>
+                    <p:cTn id="7" fill="hold">
+                      <p:stCondLst>
+                        <p:cond delay="indefinite"/>
+                      </p:stCondLst>
+                      <p:childTnLst>
+                        <p:par>
+                          <p:cTn id="8" fill="hold">
+                            <p:stCondLst>
+                              <p:cond delay="0"/>
+                            </p:stCondLst>
+                            <p:childTnLst>
+                              <p:par>
+                                <p:cTn id="9" presetID="1" presetClass="entr" presetSubtype="0" fill="hold" nodeType="clickEffect">
+                                  <p:stCondLst>
+                                    <p:cond delay="0"/>
+                                  </p:stCondLst>
+                                  <p:childTnLst>
+                                    <p:set>
+                                      <p:cBhvr>
+                                        <p:cTn id="10" dur="1" fill="hold">
+                                          <p:stCondLst>
+                                            <p:cond delay="0"/>
+                                          </p:stCondLst>
+                                        </p:cTn>
+                                        <p:tgtEl>
+                                          <p:spTgt spid="3">
+                                            <p:txEl>
+                                              <p:pRg st="5" end="5"/>
+                                            </p:txEl>
+                                          </p:spTgt>
+                                        </p:tgtEl>
+                                        <p:attrNameLst>
+                                          <p:attrName>style.visibility</p:attrName>
+                                        </p:attrNameLst>
+                                      </p:cBhvr>
+                                      <p:to>
+                                        <p:strVal val="visible"/>
+                                      </p:to>
+                                    </p:set>
+                                  </p:childTnLst>
+                                </p:cTn>
+                              </p:par>
+                            </p:childTnLst>
+                          </p:cTn>
+                        </p:par>
+                      </p:childTnLst>
+                    </p:cTn>
+                  </p:par>
                 </p:childTnLst>
               </p:cTn>
               <p:prevCondLst>
@@ -27197,7 +27284,7 @@
           <a:p>
             <a:fld id="{334F72C3-CDF3-44A8-B602-1649B1728485}" type="datetime3">
               <a:rPr lang="en-US" smtClean="0"/>
-              <a:t>18 June 2026</a:t>
+              <a:t>23 June 2026</a:t>
             </a:fld>
             <a:endParaRPr lang="en-US"/>
           </a:p>
@@ -28026,7 +28113,7 @@
           <a:p>
             <a:fld id="{334F72C3-CDF3-44A8-B602-1649B1728485}" type="datetime3">
               <a:rPr lang="en-US" smtClean="0"/>
-              <a:t>18 June 2026</a:t>
+              <a:t>23 June 2026</a:t>
             </a:fld>
             <a:endParaRPr lang="en-US"/>
           </a:p>
@@ -28304,7 +28391,13 @@
   <p:cSld>
     <p:spTree>
       <p:nvGrpSpPr>
-        <p:cNvPr id="1" name=""/>
+        <p:cNvPr id="1" name="">
+          <a:extLst>
+            <a:ext uri="{FF2B5EF4-FFF2-40B4-BE49-F238E27FC236}">
+              <a16:creationId xmlns:a16="http://schemas.microsoft.com/office/drawing/2014/main" id="{DFB26F4B-5E83-4B47-84D7-63BA29904090}"/>
+            </a:ext>
+          </a:extLst>
+        </p:cNvPr>
         <p:cNvGrpSpPr/>
         <p:nvPr/>
       </p:nvGrpSpPr>
@@ -28321,7 +28414,7 @@
           <p:cNvPr id="2" name="Title 1">
             <a:extLst>
               <a:ext uri="{FF2B5EF4-FFF2-40B4-BE49-F238E27FC236}">
-                <a16:creationId xmlns:a16="http://schemas.microsoft.com/office/drawing/2014/main" id="{AFBE7449-8A14-8E4E-1773-68687CF077E7}"/>
+                <a16:creationId xmlns:a16="http://schemas.microsoft.com/office/drawing/2014/main" id="{88C8DE70-BA89-716C-844C-AB55D23ABA1F}"/>
               </a:ext>
             </a:extLst>
           </p:cNvPr>
@@ -28339,17 +28432,17 @@
           <a:p>
             <a:r>
               <a:rPr lang="en-US" dirty="0"/>
-              <a:t>DRY</a:t>
-            </a:r>
-          </a:p>
-        </p:txBody>
-      </p:sp>
-      <p:sp>
-        <p:nvSpPr>
-          <p:cNvPr id="3" name="Content Placeholder 2">
-            <a:extLst>
-              <a:ext uri="{FF2B5EF4-FFF2-40B4-BE49-F238E27FC236}">
-                <a16:creationId xmlns:a16="http://schemas.microsoft.com/office/drawing/2014/main" id="{85EFD7A7-318A-9FEF-28C1-5F14AE540E72}"/>
+              <a:t>Another Example</a:t>
+            </a:r>
+          </a:p>
+        </p:txBody>
+      </p:sp>
+      <p:sp>
+        <p:nvSpPr>
+          <p:cNvPr id="5" name="Date Placeholder 4">
+            <a:extLst>
+              <a:ext uri="{FF2B5EF4-FFF2-40B4-BE49-F238E27FC236}">
+                <a16:creationId xmlns:a16="http://schemas.microsoft.com/office/drawing/2014/main" id="{C33F2B29-BC29-AA1C-BCA4-1AE67354D99D}"/>
               </a:ext>
             </a:extLst>
           </p:cNvPr>
@@ -28357,7 +28450,7 @@
             <a:spLocks noGrp="1"/>
           </p:cNvSpPr>
           <p:nvPr>
-            <p:ph idx="1"/>
+            <p:ph type="dt" sz="half" idx="10"/>
           </p:nvPr>
         </p:nvSpPr>
         <p:spPr/>
@@ -28365,111 +28458,9 @@
           <a:bodyPr/>
           <a:lstStyle/>
           <a:p>
-            <a:r>
-              <a:rPr lang="en-US" dirty="0"/>
-              <a:t>Case 1:</a:t>
-            </a:r>
-          </a:p>
-          <a:p>
-            <a:pPr lvl="1"/>
-            <a:r>
-              <a:rPr lang="en-US" dirty="0"/>
-              <a:t>Consistent config / setup</a:t>
-            </a:r>
-          </a:p>
-          <a:p>
-            <a:pPr lvl="1"/>
-            <a:r>
-              <a:rPr lang="en-US" dirty="0"/>
-              <a:t>Consistent parameters</a:t>
-            </a:r>
-          </a:p>
-          <a:p>
-            <a:r>
-              <a:rPr lang="en-US" dirty="0"/>
-              <a:t>Case 2:</a:t>
-            </a:r>
-          </a:p>
-          <a:p>
-            <a:pPr lvl="1"/>
-            <a:r>
-              <a:rPr lang="en-US" dirty="0"/>
-              <a:t>Input data generally stays the same</a:t>
-            </a:r>
-          </a:p>
-          <a:p>
-            <a:pPr lvl="1"/>
-            <a:r>
-              <a:rPr lang="en-US" dirty="0"/>
-              <a:t>Multiple functions might need the same inputs</a:t>
-            </a:r>
-          </a:p>
-          <a:p>
-            <a:pPr lvl="1"/>
-            <a:r>
-              <a:rPr lang="en-US" dirty="0"/>
-              <a:t>Have to write the same input data for each test?</a:t>
-            </a:r>
-          </a:p>
-          <a:p>
-            <a:r>
-              <a:rPr lang="en-US" dirty="0"/>
-              <a:t>Case 3:</a:t>
-            </a:r>
-          </a:p>
-          <a:p>
-            <a:pPr lvl="1"/>
-            <a:r>
-              <a:rPr lang="en-US" dirty="0"/>
-              <a:t>Specific objects might take a while to instantiate</a:t>
-            </a:r>
-          </a:p>
-          <a:p>
-            <a:pPr lvl="1"/>
-            <a:r>
-              <a:rPr lang="en-US" dirty="0"/>
-              <a:t>We want our tests to be fast</a:t>
-            </a:r>
-          </a:p>
-          <a:p>
-            <a:pPr lvl="1"/>
-            <a:r>
-              <a:rPr lang="en-US" dirty="0"/>
-              <a:t>Preload those objects </a:t>
-            </a:r>
-          </a:p>
-          <a:p>
-            <a:endParaRPr lang="en-US" dirty="0"/>
-          </a:p>
-          <a:p>
-            <a:endParaRPr lang="en-US" dirty="0"/>
-          </a:p>
-        </p:txBody>
-      </p:sp>
-      <p:sp>
-        <p:nvSpPr>
-          <p:cNvPr id="4" name="Date Placeholder 3">
-            <a:extLst>
-              <a:ext uri="{FF2B5EF4-FFF2-40B4-BE49-F238E27FC236}">
-                <a16:creationId xmlns:a16="http://schemas.microsoft.com/office/drawing/2014/main" id="{8B55FC9A-DC16-0D9D-1583-AC865242E328}"/>
-              </a:ext>
-            </a:extLst>
-          </p:cNvPr>
-          <p:cNvSpPr>
-            <a:spLocks noGrp="1"/>
-          </p:cNvSpPr>
-          <p:nvPr>
-            <p:ph type="dt" sz="half" idx="10"/>
-          </p:nvPr>
-        </p:nvSpPr>
-        <p:spPr/>
-        <p:txBody>
-          <a:bodyPr/>
-          <a:lstStyle/>
-          <a:p>
-            <a:fld id="{AD622D1A-DF83-41A8-85FF-04D90BF831D3}" type="datetime3">
+            <a:fld id="{334F72C3-CDF3-44A8-B602-1649B1728485}" type="datetime3">
               <a:rPr lang="en-US" smtClean="0"/>
-              <a:t>18 June 2026</a:t>
+              <a:t>23 June 2026</a:t>
             </a:fld>
             <a:endParaRPr lang="en-US"/>
           </a:p>
@@ -28477,10 +28468,10 @@
       </p:sp>
       <p:sp>
         <p:nvSpPr>
-          <p:cNvPr id="5" name="Slide Number Placeholder 4">
-            <a:extLst>
-              <a:ext uri="{FF2B5EF4-FFF2-40B4-BE49-F238E27FC236}">
-                <a16:creationId xmlns:a16="http://schemas.microsoft.com/office/drawing/2014/main" id="{DB08E3C8-C147-89EA-F9F4-7977B79D869D}"/>
+          <p:cNvPr id="6" name="Slide Number Placeholder 5">
+            <a:extLst>
+              <a:ext uri="{FF2B5EF4-FFF2-40B4-BE49-F238E27FC236}">
+                <a16:creationId xmlns:a16="http://schemas.microsoft.com/office/drawing/2014/main" id="{4D6545E6-0F79-B165-7A38-03D716C9189A}"/>
               </a:ext>
             </a:extLst>
           </p:cNvPr>
@@ -28505,16 +28496,518 @@
           </a:p>
         </p:txBody>
       </p:sp>
+      <p:sp>
+        <p:nvSpPr>
+          <p:cNvPr id="8" name="TextBox 7">
+            <a:extLst>
+              <a:ext uri="{FF2B5EF4-FFF2-40B4-BE49-F238E27FC236}">
+                <a16:creationId xmlns:a16="http://schemas.microsoft.com/office/drawing/2014/main" id="{9749C0A6-2CF5-927D-4E8F-6BC0AE1DDEB0}"/>
+              </a:ext>
+            </a:extLst>
+          </p:cNvPr>
+          <p:cNvSpPr txBox="1"/>
+          <p:nvPr/>
+        </p:nvSpPr>
+        <p:spPr>
+          <a:xfrm>
+            <a:off x="2883560" y="1423223"/>
+            <a:ext cx="4572000" cy="1709442"/>
+          </a:xfrm>
+          <a:prstGeom prst="rect">
+            <a:avLst/>
+          </a:prstGeom>
+          <a:noFill/>
+        </p:spPr>
+        <p:txBody>
+          <a:bodyPr wrap="square">
+            <a:spAutoFit/>
+          </a:bodyPr>
+          <a:lstStyle/>
+          <a:p>
+            <a:pPr>
+              <a:lnSpc>
+                <a:spcPts val="1425"/>
+              </a:lnSpc>
+              <a:buNone/>
+            </a:pPr>
+            <a:r>
+              <a:rPr lang="en-US" b="0" dirty="0">
+                <a:solidFill>
+                  <a:srgbClr val="0000FF"/>
+                </a:solidFill>
+                <a:effectLst/>
+                <a:latin typeface="Consolas" panose="020B0609020204030204" pitchFamily="49" charset="0"/>
+              </a:rPr>
+              <a:t>def</a:t>
+            </a:r>
+            <a:r>
+              <a:rPr lang="en-US" b="0" dirty="0">
+                <a:solidFill>
+                  <a:srgbClr val="000000"/>
+                </a:solidFill>
+                <a:effectLst/>
+                <a:latin typeface="Consolas" panose="020B0609020204030204" pitchFamily="49" charset="0"/>
+              </a:rPr>
+              <a:t> </a:t>
+            </a:r>
+            <a:r>
+              <a:rPr lang="en-US" b="0" dirty="0">
+                <a:solidFill>
+                  <a:srgbClr val="795E26"/>
+                </a:solidFill>
+                <a:effectLst/>
+                <a:latin typeface="Consolas" panose="020B0609020204030204" pitchFamily="49" charset="0"/>
+              </a:rPr>
+              <a:t>sin</a:t>
+            </a:r>
+            <a:r>
+              <a:rPr lang="en-US" b="0" dirty="0">
+                <a:solidFill>
+                  <a:srgbClr val="000000"/>
+                </a:solidFill>
+                <a:effectLst/>
+                <a:latin typeface="Consolas" panose="020B0609020204030204" pitchFamily="49" charset="0"/>
+              </a:rPr>
+              <a:t>(</a:t>
+            </a:r>
+            <a:r>
+              <a:rPr lang="en-US" b="0" dirty="0">
+                <a:solidFill>
+                  <a:srgbClr val="001080"/>
+                </a:solidFill>
+                <a:effectLst/>
+                <a:latin typeface="Consolas" panose="020B0609020204030204" pitchFamily="49" charset="0"/>
+              </a:rPr>
+              <a:t>num</a:t>
+            </a:r>
+            <a:r>
+              <a:rPr lang="en-US" b="0" dirty="0">
+                <a:solidFill>
+                  <a:srgbClr val="000000"/>
+                </a:solidFill>
+                <a:effectLst/>
+                <a:latin typeface="Consolas" panose="020B0609020204030204" pitchFamily="49" charset="0"/>
+              </a:rPr>
+              <a:t>: </a:t>
+            </a:r>
+            <a:r>
+              <a:rPr lang="en-US" b="0" dirty="0">
+                <a:solidFill>
+                  <a:srgbClr val="267F99"/>
+                </a:solidFill>
+                <a:effectLst/>
+                <a:latin typeface="Consolas" panose="020B0609020204030204" pitchFamily="49" charset="0"/>
+              </a:rPr>
+              <a:t>int</a:t>
+            </a:r>
+            <a:r>
+              <a:rPr lang="en-US" b="0" dirty="0">
+                <a:solidFill>
+                  <a:srgbClr val="000000"/>
+                </a:solidFill>
+                <a:effectLst/>
+                <a:latin typeface="Consolas" panose="020B0609020204030204" pitchFamily="49" charset="0"/>
+              </a:rPr>
+              <a:t>) -&gt; </a:t>
+            </a:r>
+            <a:r>
+              <a:rPr lang="en-US" b="0" dirty="0">
+                <a:solidFill>
+                  <a:srgbClr val="267F99"/>
+                </a:solidFill>
+                <a:effectLst/>
+                <a:latin typeface="Consolas" panose="020B0609020204030204" pitchFamily="49" charset="0"/>
+              </a:rPr>
+              <a:t>int</a:t>
+            </a:r>
+            <a:r>
+              <a:rPr lang="en-US" b="0" dirty="0">
+                <a:solidFill>
+                  <a:srgbClr val="000000"/>
+                </a:solidFill>
+                <a:effectLst/>
+                <a:latin typeface="Consolas" panose="020B0609020204030204" pitchFamily="49" charset="0"/>
+              </a:rPr>
+              <a:t>:</a:t>
+            </a:r>
+          </a:p>
+          <a:p>
+            <a:pPr>
+              <a:lnSpc>
+                <a:spcPts val="1425"/>
+              </a:lnSpc>
+              <a:buNone/>
+            </a:pPr>
+            <a:r>
+              <a:rPr lang="en-US" b="0" dirty="0">
+                <a:solidFill>
+                  <a:srgbClr val="000000"/>
+                </a:solidFill>
+                <a:effectLst/>
+                <a:latin typeface="Consolas" panose="020B0609020204030204" pitchFamily="49" charset="0"/>
+              </a:rPr>
+              <a:t>    </a:t>
+            </a:r>
+            <a:r>
+              <a:rPr lang="en-US" b="0" dirty="0">
+                <a:solidFill>
+                  <a:srgbClr val="AF00DB"/>
+                </a:solidFill>
+                <a:effectLst/>
+                <a:latin typeface="Consolas" panose="020B0609020204030204" pitchFamily="49" charset="0"/>
+              </a:rPr>
+              <a:t>return</a:t>
+            </a:r>
+            <a:r>
+              <a:rPr lang="en-US" b="0" dirty="0">
+                <a:solidFill>
+                  <a:srgbClr val="000000"/>
+                </a:solidFill>
+                <a:effectLst/>
+                <a:latin typeface="Consolas" panose="020B0609020204030204" pitchFamily="49" charset="0"/>
+              </a:rPr>
+              <a:t> </a:t>
+            </a:r>
+            <a:r>
+              <a:rPr lang="en-US" dirty="0">
+                <a:solidFill>
+                  <a:srgbClr val="001080"/>
+                </a:solidFill>
+                <a:latin typeface="Consolas" panose="020B0609020204030204" pitchFamily="49" charset="0"/>
+              </a:rPr>
+              <a:t>0</a:t>
+            </a:r>
+            <a:endParaRPr lang="en-US" b="0" dirty="0">
+              <a:solidFill>
+                <a:srgbClr val="000000"/>
+              </a:solidFill>
+              <a:effectLst/>
+              <a:latin typeface="Consolas" panose="020B0609020204030204" pitchFamily="49" charset="0"/>
+            </a:endParaRPr>
+          </a:p>
+          <a:p>
+            <a:pPr>
+              <a:lnSpc>
+                <a:spcPts val="1425"/>
+              </a:lnSpc>
+              <a:buNone/>
+            </a:pPr>
+            <a:br>
+              <a:rPr lang="en-US" b="0" dirty="0">
+                <a:solidFill>
+                  <a:srgbClr val="000000"/>
+                </a:solidFill>
+                <a:effectLst/>
+                <a:latin typeface="Consolas" panose="020B0609020204030204" pitchFamily="49" charset="0"/>
+              </a:rPr>
+            </a:br>
+            <a:br>
+              <a:rPr lang="en-US" b="0" dirty="0">
+                <a:solidFill>
+                  <a:srgbClr val="000000"/>
+                </a:solidFill>
+                <a:effectLst/>
+                <a:latin typeface="Consolas" panose="020B0609020204030204" pitchFamily="49" charset="0"/>
+              </a:rPr>
+            </a:br>
+            <a:endParaRPr lang="en-US" b="0" dirty="0">
+              <a:solidFill>
+                <a:srgbClr val="000000"/>
+              </a:solidFill>
+              <a:effectLst/>
+              <a:latin typeface="Consolas" panose="020B0609020204030204" pitchFamily="49" charset="0"/>
+            </a:endParaRPr>
+          </a:p>
+          <a:p>
+            <a:pPr>
+              <a:lnSpc>
+                <a:spcPts val="1425"/>
+              </a:lnSpc>
+              <a:buNone/>
+            </a:pPr>
+            <a:r>
+              <a:rPr lang="en-US" b="0" dirty="0">
+                <a:solidFill>
+                  <a:srgbClr val="0000FF"/>
+                </a:solidFill>
+                <a:effectLst/>
+                <a:latin typeface="Consolas" panose="020B0609020204030204" pitchFamily="49" charset="0"/>
+              </a:rPr>
+              <a:t>def</a:t>
+            </a:r>
+            <a:r>
+              <a:rPr lang="en-US" b="0" dirty="0">
+                <a:solidFill>
+                  <a:srgbClr val="000000"/>
+                </a:solidFill>
+                <a:effectLst/>
+                <a:latin typeface="Consolas" panose="020B0609020204030204" pitchFamily="49" charset="0"/>
+              </a:rPr>
+              <a:t> </a:t>
+            </a:r>
+            <a:r>
+              <a:rPr lang="en-US" b="0" dirty="0" err="1">
+                <a:solidFill>
+                  <a:srgbClr val="795E26"/>
+                </a:solidFill>
+                <a:effectLst/>
+                <a:latin typeface="Consolas" panose="020B0609020204030204" pitchFamily="49" charset="0"/>
+              </a:rPr>
+              <a:t>test_sin</a:t>
+            </a:r>
+            <a:r>
+              <a:rPr lang="en-US" b="0" dirty="0">
+                <a:solidFill>
+                  <a:srgbClr val="000000"/>
+                </a:solidFill>
+                <a:effectLst/>
+                <a:latin typeface="Consolas" panose="020B0609020204030204" pitchFamily="49" charset="0"/>
+              </a:rPr>
+              <a:t>():</a:t>
+            </a:r>
+          </a:p>
+          <a:p>
+            <a:pPr>
+              <a:lnSpc>
+                <a:spcPts val="1425"/>
+              </a:lnSpc>
+              <a:buNone/>
+            </a:pPr>
+            <a:r>
+              <a:rPr lang="en-US" b="0" dirty="0">
+                <a:solidFill>
+                  <a:srgbClr val="000000"/>
+                </a:solidFill>
+                <a:effectLst/>
+                <a:latin typeface="Consolas" panose="020B0609020204030204" pitchFamily="49" charset="0"/>
+              </a:rPr>
+              <a:t>    </a:t>
+            </a:r>
+            <a:r>
+              <a:rPr lang="en-US" b="0" dirty="0">
+                <a:solidFill>
+                  <a:srgbClr val="AF00DB"/>
+                </a:solidFill>
+                <a:effectLst/>
+                <a:latin typeface="Consolas" panose="020B0609020204030204" pitchFamily="49" charset="0"/>
+              </a:rPr>
+              <a:t>assert</a:t>
+            </a:r>
+            <a:r>
+              <a:rPr lang="en-US" b="0" dirty="0">
+                <a:solidFill>
+                  <a:srgbClr val="000000"/>
+                </a:solidFill>
+                <a:effectLst/>
+                <a:latin typeface="Consolas" panose="020B0609020204030204" pitchFamily="49" charset="0"/>
+              </a:rPr>
+              <a:t> </a:t>
+            </a:r>
+            <a:r>
+              <a:rPr lang="en-US" b="0" dirty="0">
+                <a:solidFill>
+                  <a:srgbClr val="795E26"/>
+                </a:solidFill>
+                <a:effectLst/>
+                <a:latin typeface="Consolas" panose="020B0609020204030204" pitchFamily="49" charset="0"/>
+              </a:rPr>
+              <a:t>sin</a:t>
+            </a:r>
+            <a:r>
+              <a:rPr lang="en-US" b="0" dirty="0">
+                <a:solidFill>
+                  <a:srgbClr val="000000"/>
+                </a:solidFill>
+                <a:effectLst/>
+                <a:latin typeface="Consolas" panose="020B0609020204030204" pitchFamily="49" charset="0"/>
+              </a:rPr>
+              <a:t>(</a:t>
+            </a:r>
+            <a:r>
+              <a:rPr lang="en-US" dirty="0">
+                <a:solidFill>
+                  <a:srgbClr val="098658"/>
+                </a:solidFill>
+                <a:latin typeface="Consolas" panose="020B0609020204030204" pitchFamily="49" charset="0"/>
+              </a:rPr>
+              <a:t>0</a:t>
+            </a:r>
+            <a:r>
+              <a:rPr lang="en-US" b="0" dirty="0">
+                <a:solidFill>
+                  <a:srgbClr val="000000"/>
+                </a:solidFill>
+                <a:effectLst/>
+                <a:latin typeface="Consolas" panose="020B0609020204030204" pitchFamily="49" charset="0"/>
+              </a:rPr>
+              <a:t>) == </a:t>
+            </a:r>
+            <a:r>
+              <a:rPr lang="en-US" dirty="0">
+                <a:solidFill>
+                  <a:srgbClr val="001080"/>
+                </a:solidFill>
+                <a:latin typeface="Consolas" panose="020B0609020204030204" pitchFamily="49" charset="0"/>
+              </a:rPr>
+              <a:t>0</a:t>
+            </a:r>
+            <a:endParaRPr lang="en-US" b="0" dirty="0">
+              <a:solidFill>
+                <a:srgbClr val="000000"/>
+              </a:solidFill>
+              <a:effectLst/>
+              <a:latin typeface="Consolas" panose="020B0609020204030204" pitchFamily="49" charset="0"/>
+            </a:endParaRPr>
+          </a:p>
+          <a:p>
+            <a:pPr>
+              <a:lnSpc>
+                <a:spcPts val="1425"/>
+              </a:lnSpc>
+              <a:buNone/>
+            </a:pPr>
+            <a:br>
+              <a:rPr lang="en-US" b="0" dirty="0">
+                <a:solidFill>
+                  <a:srgbClr val="000000"/>
+                </a:solidFill>
+                <a:effectLst/>
+                <a:latin typeface="Consolas" panose="020B0609020204030204" pitchFamily="49" charset="0"/>
+              </a:rPr>
+            </a:br>
+            <a:endParaRPr lang="en-US" b="0" dirty="0">
+              <a:solidFill>
+                <a:srgbClr val="000000"/>
+              </a:solidFill>
+              <a:effectLst/>
+              <a:latin typeface="Consolas" panose="020B0609020204030204" pitchFamily="49" charset="0"/>
+            </a:endParaRPr>
+          </a:p>
+        </p:txBody>
+      </p:sp>
+      <p:sp>
+        <p:nvSpPr>
+          <p:cNvPr id="11" name="TextBox 10">
+            <a:extLst>
+              <a:ext uri="{FF2B5EF4-FFF2-40B4-BE49-F238E27FC236}">
+                <a16:creationId xmlns:a16="http://schemas.microsoft.com/office/drawing/2014/main" id="{88E2CABD-4DD2-387E-194D-440EB61303E6}"/>
+              </a:ext>
+            </a:extLst>
+          </p:cNvPr>
+          <p:cNvSpPr txBox="1"/>
+          <p:nvPr/>
+        </p:nvSpPr>
+        <p:spPr>
+          <a:xfrm>
+            <a:off x="1706939" y="3403107"/>
+            <a:ext cx="5730121" cy="830997"/>
+          </a:xfrm>
+          <a:prstGeom prst="rect">
+            <a:avLst/>
+          </a:prstGeom>
+          <a:noFill/>
+        </p:spPr>
+        <p:txBody>
+          <a:bodyPr wrap="square">
+            <a:spAutoFit/>
+          </a:bodyPr>
+          <a:lstStyle/>
+          <a:p>
+            <a:r>
+              <a:rPr lang="en-US" sz="2400" dirty="0"/>
+              <a:t>Tests should be complete, independent, reproducible, and small!!</a:t>
+            </a:r>
+          </a:p>
+        </p:txBody>
+      </p:sp>
     </p:spTree>
     <p:extLst>
       <p:ext uri="{BB962C8B-B14F-4D97-AF65-F5344CB8AC3E}">
-        <p14:creationId xmlns:p14="http://schemas.microsoft.com/office/powerpoint/2010/main" val="1953408799"/>
+        <p14:creationId xmlns:p14="http://schemas.microsoft.com/office/powerpoint/2010/main" val="2086239113"/>
       </p:ext>
     </p:extLst>
   </p:cSld>
   <p:clrMapOvr>
     <a:masterClrMapping/>
   </p:clrMapOvr>
+  <p:timing>
+    <p:tnLst>
+      <p:par>
+        <p:cTn id="1" dur="indefinite" restart="never" nodeType="tmRoot">
+          <p:childTnLst>
+            <p:seq concurrent="1" nextAc="seek">
+              <p:cTn id="2" dur="indefinite" nodeType="mainSeq">
+                <p:childTnLst>
+                  <p:par>
+                    <p:cTn id="3" fill="hold">
+                      <p:stCondLst>
+                        <p:cond delay="indefinite"/>
+                      </p:stCondLst>
+                      <p:childTnLst>
+                        <p:par>
+                          <p:cTn id="4" fill="hold">
+                            <p:stCondLst>
+                              <p:cond delay="0"/>
+                            </p:stCondLst>
+                            <p:childTnLst>
+                              <p:par>
+                                <p:cTn id="5" presetID="1" presetClass="entr" presetSubtype="0" fill="hold" grpId="0" nodeType="clickEffect">
+                                  <p:stCondLst>
+                                    <p:cond delay="0"/>
+                                  </p:stCondLst>
+                                  <p:childTnLst>
+                                    <p:set>
+                                      <p:cBhvr>
+                                        <p:cTn id="6" dur="1" fill="hold">
+                                          <p:stCondLst>
+                                            <p:cond delay="0"/>
+                                          </p:stCondLst>
+                                        </p:cTn>
+                                        <p:tgtEl>
+                                          <p:spTgt spid="11"/>
+                                        </p:tgtEl>
+                                        <p:attrNameLst>
+                                          <p:attrName>style.visibility</p:attrName>
+                                        </p:attrNameLst>
+                                      </p:cBhvr>
+                                      <p:to>
+                                        <p:strVal val="visible"/>
+                                      </p:to>
+                                    </p:set>
+                                  </p:childTnLst>
+                                </p:cTn>
+                              </p:par>
+                            </p:childTnLst>
+                          </p:cTn>
+                        </p:par>
+                      </p:childTnLst>
+                    </p:cTn>
+                  </p:par>
+                </p:childTnLst>
+              </p:cTn>
+              <p:prevCondLst>
+                <p:cond evt="onPrev" delay="0">
+                  <p:tgtEl>
+                    <p:sldTgt/>
+                  </p:tgtEl>
+                </p:cond>
+              </p:prevCondLst>
+              <p:nextCondLst>
+                <p:cond evt="onNext" delay="0">
+                  <p:tgtEl>
+                    <p:sldTgt/>
+                  </p:tgtEl>
+                </p:cond>
+              </p:nextCondLst>
+            </p:seq>
+          </p:childTnLst>
+        </p:cTn>
+      </p:par>
+    </p:tnLst>
+    <p:bldLst>
+      <p:bldP spid="11" grpId="0"/>
+    </p:bldLst>
+  </p:timing>
 </p:sld>
 </file>
 
@@ -28540,7 +29033,7 @@
           <p:cNvPr id="2" name="Title 1">
             <a:extLst>
               <a:ext uri="{FF2B5EF4-FFF2-40B4-BE49-F238E27FC236}">
-                <a16:creationId xmlns:a16="http://schemas.microsoft.com/office/drawing/2014/main" id="{914E8921-BD4D-5B6E-2FBA-F2836DE0BD9D}"/>
+                <a16:creationId xmlns:a16="http://schemas.microsoft.com/office/drawing/2014/main" id="{AFBE7449-8A14-8E4E-1773-68687CF077E7}"/>
               </a:ext>
             </a:extLst>
           </p:cNvPr>
@@ -28558,57 +29051,25 @@
           <a:p>
             <a:r>
               <a:rPr lang="en-US" dirty="0"/>
-              <a:t>Fixtures</a:t>
-            </a:r>
-          </a:p>
-        </p:txBody>
-      </p:sp>
-      <p:pic>
-        <p:nvPicPr>
-          <p:cNvPr id="7" name="Content Placeholder 6">
-            <a:extLst>
-              <a:ext uri="{FF2B5EF4-FFF2-40B4-BE49-F238E27FC236}">
-                <a16:creationId xmlns:a16="http://schemas.microsoft.com/office/drawing/2014/main" id="{3762C841-FABF-D46F-FC8F-616B8BE6BE0B}"/>
-              </a:ext>
-            </a:extLst>
-          </p:cNvPr>
-          <p:cNvPicPr>
-            <a:picLocks noGrp="1" noChangeAspect="1"/>
-          </p:cNvPicPr>
+              <a:t>DRY</a:t>
+            </a:r>
+          </a:p>
+        </p:txBody>
+      </p:sp>
+      <p:sp>
+        <p:nvSpPr>
+          <p:cNvPr id="3" name="Content Placeholder 2">
+            <a:extLst>
+              <a:ext uri="{FF2B5EF4-FFF2-40B4-BE49-F238E27FC236}">
+                <a16:creationId xmlns:a16="http://schemas.microsoft.com/office/drawing/2014/main" id="{85EFD7A7-318A-9FEF-28C1-5F14AE540E72}"/>
+              </a:ext>
+            </a:extLst>
+          </p:cNvPr>
+          <p:cNvSpPr>
+            <a:spLocks noGrp="1"/>
+          </p:cNvSpPr>
           <p:nvPr>
             <p:ph idx="1"/>
-          </p:nvPr>
-        </p:nvPicPr>
-        <p:blipFill>
-          <a:blip r:embed="rId3"/>
-          <a:stretch>
-            <a:fillRect/>
-          </a:stretch>
-        </p:blipFill>
-        <p:spPr>
-          <a:xfrm>
-            <a:off x="827365" y="1052454"/>
-            <a:ext cx="7115988" cy="3358480"/>
-          </a:xfrm>
-          <a:prstGeom prst="rect">
-            <a:avLst/>
-          </a:prstGeom>
-        </p:spPr>
-      </p:pic>
-      <p:sp>
-        <p:nvSpPr>
-          <p:cNvPr id="4" name="Date Placeholder 3">
-            <a:extLst>
-              <a:ext uri="{FF2B5EF4-FFF2-40B4-BE49-F238E27FC236}">
-                <a16:creationId xmlns:a16="http://schemas.microsoft.com/office/drawing/2014/main" id="{DE0531EB-F71B-5C5F-1F1F-F121CA1CD462}"/>
-              </a:ext>
-            </a:extLst>
-          </p:cNvPr>
-          <p:cNvSpPr>
-            <a:spLocks noGrp="1"/>
-          </p:cNvSpPr>
-          <p:nvPr>
-            <p:ph type="dt" sz="half" idx="10"/>
           </p:nvPr>
         </p:nvSpPr>
         <p:spPr/>
@@ -28616,9 +29077,111 @@
           <a:bodyPr/>
           <a:lstStyle/>
           <a:p>
+            <a:r>
+              <a:rPr lang="en-US" dirty="0"/>
+              <a:t>Case 1:</a:t>
+            </a:r>
+          </a:p>
+          <a:p>
+            <a:pPr lvl="1"/>
+            <a:r>
+              <a:rPr lang="en-US" dirty="0"/>
+              <a:t>Consistent config / setup</a:t>
+            </a:r>
+          </a:p>
+          <a:p>
+            <a:pPr lvl="1"/>
+            <a:r>
+              <a:rPr lang="en-US" dirty="0"/>
+              <a:t>Consistent parameters</a:t>
+            </a:r>
+          </a:p>
+          <a:p>
+            <a:r>
+              <a:rPr lang="en-US" dirty="0"/>
+              <a:t>Case 2:</a:t>
+            </a:r>
+          </a:p>
+          <a:p>
+            <a:pPr lvl="1"/>
+            <a:r>
+              <a:rPr lang="en-US" dirty="0"/>
+              <a:t>Input data generally stays the same</a:t>
+            </a:r>
+          </a:p>
+          <a:p>
+            <a:pPr lvl="1"/>
+            <a:r>
+              <a:rPr lang="en-US" dirty="0"/>
+              <a:t>Multiple functions might need the same inputs</a:t>
+            </a:r>
+          </a:p>
+          <a:p>
+            <a:pPr lvl="1"/>
+            <a:r>
+              <a:rPr lang="en-US" dirty="0"/>
+              <a:t>Have to write the same input data for each test?</a:t>
+            </a:r>
+          </a:p>
+          <a:p>
+            <a:r>
+              <a:rPr lang="en-US" dirty="0"/>
+              <a:t>Case 3:</a:t>
+            </a:r>
+          </a:p>
+          <a:p>
+            <a:pPr lvl="1"/>
+            <a:r>
+              <a:rPr lang="en-US" dirty="0"/>
+              <a:t>Specific objects might take a while to instantiate</a:t>
+            </a:r>
+          </a:p>
+          <a:p>
+            <a:pPr lvl="1"/>
+            <a:r>
+              <a:rPr lang="en-US" dirty="0"/>
+              <a:t>We want our tests to be fast</a:t>
+            </a:r>
+          </a:p>
+          <a:p>
+            <a:pPr lvl="1"/>
+            <a:r>
+              <a:rPr lang="en-US" dirty="0"/>
+              <a:t>Preload those objects </a:t>
+            </a:r>
+          </a:p>
+          <a:p>
+            <a:endParaRPr lang="en-US" dirty="0"/>
+          </a:p>
+          <a:p>
+            <a:endParaRPr lang="en-US" dirty="0"/>
+          </a:p>
+        </p:txBody>
+      </p:sp>
+      <p:sp>
+        <p:nvSpPr>
+          <p:cNvPr id="4" name="Date Placeholder 3">
+            <a:extLst>
+              <a:ext uri="{FF2B5EF4-FFF2-40B4-BE49-F238E27FC236}">
+                <a16:creationId xmlns:a16="http://schemas.microsoft.com/office/drawing/2014/main" id="{8B55FC9A-DC16-0D9D-1583-AC865242E328}"/>
+              </a:ext>
+            </a:extLst>
+          </p:cNvPr>
+          <p:cNvSpPr>
+            <a:spLocks noGrp="1"/>
+          </p:cNvSpPr>
+          <p:nvPr>
+            <p:ph type="dt" sz="half" idx="10"/>
+          </p:nvPr>
+        </p:nvSpPr>
+        <p:spPr/>
+        <p:txBody>
+          <a:bodyPr/>
+          <a:lstStyle/>
+          <a:p>
             <a:fld id="{AD622D1A-DF83-41A8-85FF-04D90BF831D3}" type="datetime3">
               <a:rPr lang="en-US" smtClean="0"/>
-              <a:t>18 June 2026</a:t>
+              <a:t>23 June 2026</a:t>
             </a:fld>
             <a:endParaRPr lang="en-US"/>
           </a:p>
@@ -28629,7 +29192,7 @@
           <p:cNvPr id="5" name="Slide Number Placeholder 4">
             <a:extLst>
               <a:ext uri="{FF2B5EF4-FFF2-40B4-BE49-F238E27FC236}">
-                <a16:creationId xmlns:a16="http://schemas.microsoft.com/office/drawing/2014/main" id="{D5A70CB1-4188-AD39-4290-CCF8E0598AC4}"/>
+                <a16:creationId xmlns:a16="http://schemas.microsoft.com/office/drawing/2014/main" id="{DB08E3C8-C147-89EA-F9F4-7977B79D869D}"/>
               </a:ext>
             </a:extLst>
           </p:cNvPr>
@@ -28657,7 +29220,7 @@
     </p:spTree>
     <p:extLst>
       <p:ext uri="{BB962C8B-B14F-4D97-AF65-F5344CB8AC3E}">
-        <p14:creationId xmlns:p14="http://schemas.microsoft.com/office/powerpoint/2010/main" val="3139033530"/>
+        <p14:creationId xmlns:p14="http://schemas.microsoft.com/office/powerpoint/2010/main" val="1953408799"/>
       </p:ext>
     </p:extLst>
   </p:cSld>
@@ -28781,7 +29344,7 @@
           <a:p>
             <a:fld id="{D41656AB-D2E1-472E-8B95-0DF5C6E1D623}" type="datetime3">
               <a:rPr lang="en-US" smtClean="0"/>
-              <a:t>18 June 2026</a:t>
+              <a:t>23 June 2026</a:t>
             </a:fld>
             <a:endParaRPr lang="en-US"/>
           </a:p>
@@ -28852,7 +29415,7 @@
           <p:cNvPr id="2" name="Title 1">
             <a:extLst>
               <a:ext uri="{FF2B5EF4-FFF2-40B4-BE49-F238E27FC236}">
-                <a16:creationId xmlns:a16="http://schemas.microsoft.com/office/drawing/2014/main" id="{B70DDD1B-F3B0-F59F-345F-5D1C7D0E0D71}"/>
+                <a16:creationId xmlns:a16="http://schemas.microsoft.com/office/drawing/2014/main" id="{914E8921-BD4D-5B6E-2FBA-F2836DE0BD9D}"/>
               </a:ext>
             </a:extLst>
           </p:cNvPr>
@@ -28880,7 +29443,7 @@
           <p:cNvPr id="7" name="Content Placeholder 6">
             <a:extLst>
               <a:ext uri="{FF2B5EF4-FFF2-40B4-BE49-F238E27FC236}">
-                <a16:creationId xmlns:a16="http://schemas.microsoft.com/office/drawing/2014/main" id="{EB2174EE-2812-2F22-76C8-97935FAF6293}"/>
+                <a16:creationId xmlns:a16="http://schemas.microsoft.com/office/drawing/2014/main" id="{3762C841-FABF-D46F-FC8F-616B8BE6BE0B}"/>
               </a:ext>
             </a:extLst>
           </p:cNvPr>
@@ -28899,8 +29462,8 @@
         </p:blipFill>
         <p:spPr>
           <a:xfrm>
-            <a:off x="3129373" y="79031"/>
-            <a:ext cx="6014627" cy="4985437"/>
+            <a:off x="827365" y="1052454"/>
+            <a:ext cx="7115988" cy="3358480"/>
           </a:xfrm>
           <a:prstGeom prst="rect">
             <a:avLst/>
@@ -28912,7 +29475,7 @@
           <p:cNvPr id="4" name="Date Placeholder 3">
             <a:extLst>
               <a:ext uri="{FF2B5EF4-FFF2-40B4-BE49-F238E27FC236}">
-                <a16:creationId xmlns:a16="http://schemas.microsoft.com/office/drawing/2014/main" id="{ABCBFB7D-B32A-FBF3-D5F5-F1CD4FC149EC}"/>
+                <a16:creationId xmlns:a16="http://schemas.microsoft.com/office/drawing/2014/main" id="{DE0531EB-F71B-5C5F-1F1F-F121CA1CD462}"/>
               </a:ext>
             </a:extLst>
           </p:cNvPr>
@@ -28930,7 +29493,7 @@
           <a:p>
             <a:fld id="{AD622D1A-DF83-41A8-85FF-04D90BF831D3}" type="datetime3">
               <a:rPr lang="en-US" smtClean="0"/>
-              <a:t>18 June 2026</a:t>
+              <a:t>23 June 2026</a:t>
             </a:fld>
             <a:endParaRPr lang="en-US"/>
           </a:p>
@@ -28941,7 +29504,7 @@
           <p:cNvPr id="5" name="Slide Number Placeholder 4">
             <a:extLst>
               <a:ext uri="{FF2B5EF4-FFF2-40B4-BE49-F238E27FC236}">
-                <a16:creationId xmlns:a16="http://schemas.microsoft.com/office/drawing/2014/main" id="{CE8089C0-371A-E4C3-77BB-56B809D2E5A0}"/>
+                <a16:creationId xmlns:a16="http://schemas.microsoft.com/office/drawing/2014/main" id="{D5A70CB1-4188-AD39-4290-CCF8E0598AC4}"/>
               </a:ext>
             </a:extLst>
           </p:cNvPr>
@@ -28969,7 +29532,7 @@
     </p:spTree>
     <p:extLst>
       <p:ext uri="{BB962C8B-B14F-4D97-AF65-F5344CB8AC3E}">
-        <p14:creationId xmlns:p14="http://schemas.microsoft.com/office/powerpoint/2010/main" val="2828358992"/>
+        <p14:creationId xmlns:p14="http://schemas.microsoft.com/office/powerpoint/2010/main" val="3139033530"/>
       </p:ext>
     </p:extLst>
   </p:cSld>
@@ -29001,7 +29564,7 @@
           <p:cNvPr id="2" name="Title 1">
             <a:extLst>
               <a:ext uri="{FF2B5EF4-FFF2-40B4-BE49-F238E27FC236}">
-                <a16:creationId xmlns:a16="http://schemas.microsoft.com/office/drawing/2014/main" id="{4877FFEF-2D47-84E3-5D79-E149C8FAB2EB}"/>
+                <a16:creationId xmlns:a16="http://schemas.microsoft.com/office/drawing/2014/main" id="{B70DDD1B-F3B0-F59F-345F-5D1C7D0E0D71}"/>
               </a:ext>
             </a:extLst>
           </p:cNvPr>
@@ -29024,12 +29587,44 @@
           </a:p>
         </p:txBody>
       </p:sp>
+      <p:pic>
+        <p:nvPicPr>
+          <p:cNvPr id="7" name="Content Placeholder 6">
+            <a:extLst>
+              <a:ext uri="{FF2B5EF4-FFF2-40B4-BE49-F238E27FC236}">
+                <a16:creationId xmlns:a16="http://schemas.microsoft.com/office/drawing/2014/main" id="{EB2174EE-2812-2F22-76C8-97935FAF6293}"/>
+              </a:ext>
+            </a:extLst>
+          </p:cNvPr>
+          <p:cNvPicPr>
+            <a:picLocks noGrp="1" noChangeAspect="1"/>
+          </p:cNvPicPr>
+          <p:nvPr>
+            <p:ph idx="1"/>
+          </p:nvPr>
+        </p:nvPicPr>
+        <p:blipFill>
+          <a:blip r:embed="rId3"/>
+          <a:stretch>
+            <a:fillRect/>
+          </a:stretch>
+        </p:blipFill>
+        <p:spPr>
+          <a:xfrm>
+            <a:off x="3129373" y="79031"/>
+            <a:ext cx="6014627" cy="4985437"/>
+          </a:xfrm>
+          <a:prstGeom prst="rect">
+            <a:avLst/>
+          </a:prstGeom>
+        </p:spPr>
+      </p:pic>
       <p:sp>
         <p:nvSpPr>
           <p:cNvPr id="4" name="Date Placeholder 3">
             <a:extLst>
               <a:ext uri="{FF2B5EF4-FFF2-40B4-BE49-F238E27FC236}">
-                <a16:creationId xmlns:a16="http://schemas.microsoft.com/office/drawing/2014/main" id="{54EBD7C6-0C9A-08C8-D1BA-911281F6AF5F}"/>
+                <a16:creationId xmlns:a16="http://schemas.microsoft.com/office/drawing/2014/main" id="{ABCBFB7D-B32A-FBF3-D5F5-F1CD4FC149EC}"/>
               </a:ext>
             </a:extLst>
           </p:cNvPr>
@@ -29047,7 +29642,7 @@
           <a:p>
             <a:fld id="{AD622D1A-DF83-41A8-85FF-04D90BF831D3}" type="datetime3">
               <a:rPr lang="en-US" smtClean="0"/>
-              <a:t>18 June 2026</a:t>
+              <a:t>23 June 2026</a:t>
             </a:fld>
             <a:endParaRPr lang="en-US"/>
           </a:p>
@@ -29058,7 +29653,7 @@
           <p:cNvPr id="5" name="Slide Number Placeholder 4">
             <a:extLst>
               <a:ext uri="{FF2B5EF4-FFF2-40B4-BE49-F238E27FC236}">
-                <a16:creationId xmlns:a16="http://schemas.microsoft.com/office/drawing/2014/main" id="{1D5C8B6B-CA8E-CB24-2673-8ADE45EA2568}"/>
+                <a16:creationId xmlns:a16="http://schemas.microsoft.com/office/drawing/2014/main" id="{CE8089C0-371A-E4C3-77BB-56B809D2E5A0}"/>
               </a:ext>
             </a:extLst>
           </p:cNvPr>
@@ -29078,6 +29673,123 @@
               <a:rPr lang="en-US" smtClean="0"/>
               <a:pPr/>
               <a:t>21</a:t>
+            </a:fld>
+            <a:endParaRPr lang="en-US"/>
+          </a:p>
+        </p:txBody>
+      </p:sp>
+    </p:spTree>
+    <p:extLst>
+      <p:ext uri="{BB962C8B-B14F-4D97-AF65-F5344CB8AC3E}">
+        <p14:creationId xmlns:p14="http://schemas.microsoft.com/office/powerpoint/2010/main" val="2828358992"/>
+      </p:ext>
+    </p:extLst>
+  </p:cSld>
+  <p:clrMapOvr>
+    <a:masterClrMapping/>
+  </p:clrMapOvr>
+</p:sld>
+</file>
+
+<file path=ppt/slides/slide22.xml><?xml version="1.0" encoding="utf-8"?>
+<p:sld xmlns:a="http://schemas.openxmlformats.org/drawingml/2006/main" xmlns:r="http://schemas.openxmlformats.org/officeDocument/2006/relationships" xmlns:p="http://schemas.openxmlformats.org/presentationml/2006/main">
+  <p:cSld>
+    <p:spTree>
+      <p:nvGrpSpPr>
+        <p:cNvPr id="1" name=""/>
+        <p:cNvGrpSpPr/>
+        <p:nvPr/>
+      </p:nvGrpSpPr>
+      <p:grpSpPr>
+        <a:xfrm>
+          <a:off x="0" y="0"/>
+          <a:ext cx="0" cy="0"/>
+          <a:chOff x="0" y="0"/>
+          <a:chExt cx="0" cy="0"/>
+        </a:xfrm>
+      </p:grpSpPr>
+      <p:sp>
+        <p:nvSpPr>
+          <p:cNvPr id="2" name="Title 1">
+            <a:extLst>
+              <a:ext uri="{FF2B5EF4-FFF2-40B4-BE49-F238E27FC236}">
+                <a16:creationId xmlns:a16="http://schemas.microsoft.com/office/drawing/2014/main" id="{4877FFEF-2D47-84E3-5D79-E149C8FAB2EB}"/>
+              </a:ext>
+            </a:extLst>
+          </p:cNvPr>
+          <p:cNvSpPr>
+            <a:spLocks noGrp="1"/>
+          </p:cNvSpPr>
+          <p:nvPr>
+            <p:ph type="title"/>
+          </p:nvPr>
+        </p:nvSpPr>
+        <p:spPr/>
+        <p:txBody>
+          <a:bodyPr/>
+          <a:lstStyle/>
+          <a:p>
+            <a:r>
+              <a:rPr lang="en-US" dirty="0"/>
+              <a:t>Fixtures</a:t>
+            </a:r>
+          </a:p>
+        </p:txBody>
+      </p:sp>
+      <p:sp>
+        <p:nvSpPr>
+          <p:cNvPr id="4" name="Date Placeholder 3">
+            <a:extLst>
+              <a:ext uri="{FF2B5EF4-FFF2-40B4-BE49-F238E27FC236}">
+                <a16:creationId xmlns:a16="http://schemas.microsoft.com/office/drawing/2014/main" id="{54EBD7C6-0C9A-08C8-D1BA-911281F6AF5F}"/>
+              </a:ext>
+            </a:extLst>
+          </p:cNvPr>
+          <p:cNvSpPr>
+            <a:spLocks noGrp="1"/>
+          </p:cNvSpPr>
+          <p:nvPr>
+            <p:ph type="dt" sz="half" idx="10"/>
+          </p:nvPr>
+        </p:nvSpPr>
+        <p:spPr/>
+        <p:txBody>
+          <a:bodyPr/>
+          <a:lstStyle/>
+          <a:p>
+            <a:fld id="{AD622D1A-DF83-41A8-85FF-04D90BF831D3}" type="datetime3">
+              <a:rPr lang="en-US" smtClean="0"/>
+              <a:t>23 June 2026</a:t>
+            </a:fld>
+            <a:endParaRPr lang="en-US"/>
+          </a:p>
+        </p:txBody>
+      </p:sp>
+      <p:sp>
+        <p:nvSpPr>
+          <p:cNvPr id="5" name="Slide Number Placeholder 4">
+            <a:extLst>
+              <a:ext uri="{FF2B5EF4-FFF2-40B4-BE49-F238E27FC236}">
+                <a16:creationId xmlns:a16="http://schemas.microsoft.com/office/drawing/2014/main" id="{1D5C8B6B-CA8E-CB24-2673-8ADE45EA2568}"/>
+              </a:ext>
+            </a:extLst>
+          </p:cNvPr>
+          <p:cNvSpPr>
+            <a:spLocks noGrp="1"/>
+          </p:cNvSpPr>
+          <p:nvPr>
+            <p:ph type="sldNum" sz="quarter" idx="11"/>
+          </p:nvPr>
+        </p:nvSpPr>
+        <p:spPr/>
+        <p:txBody>
+          <a:bodyPr/>
+          <a:lstStyle/>
+          <a:p>
+            <a:fld id="{64E5BE4B-2FBF-4174-9E62-85FAD1CB43A6}" type="slidenum">
+              <a:rPr lang="en-US" smtClean="0"/>
+              <a:pPr/>
+              <a:t>22</a:t>
             </a:fld>
             <a:endParaRPr lang="en-US"/>
           </a:p>
@@ -29128,7 +29840,7 @@
 </p:sld>
 </file>
 
-<file path=ppt/slides/slide22.xml><?xml version="1.0" encoding="utf-8"?>
+<file path=ppt/slides/slide23.xml><?xml version="1.0" encoding="utf-8"?>
 <p:sld xmlns:a="http://schemas.openxmlformats.org/drawingml/2006/main" xmlns:r="http://schemas.openxmlformats.org/officeDocument/2006/relationships" xmlns:p="http://schemas.openxmlformats.org/presentationml/2006/main">
   <p:cSld>
     <p:spTree>
@@ -29201,7 +29913,7 @@
           <a:p>
             <a:fld id="{AD622D1A-DF83-41A8-85FF-04D90BF831D3}" type="datetime3">
               <a:rPr lang="en-US" smtClean="0"/>
-              <a:t>18 June 2026</a:t>
+              <a:t>23 June 2026</a:t>
             </a:fld>
             <a:endParaRPr lang="en-US"/>
           </a:p>
@@ -29231,7 +29943,7 @@
             <a:fld id="{64E5BE4B-2FBF-4174-9E62-85FAD1CB43A6}" type="slidenum">
               <a:rPr lang="en-US" smtClean="0"/>
               <a:pPr/>
-              <a:t>22</a:t>
+              <a:t>23</a:t>
             </a:fld>
             <a:endParaRPr lang="en-US"/>
           </a:p>
@@ -29252,7 +29964,7 @@
         <p:spPr>
           <a:xfrm>
             <a:off x="719732" y="1336317"/>
-            <a:ext cx="7704536" cy="2248051"/>
+            <a:ext cx="7704536" cy="2171107"/>
           </a:xfrm>
           <a:prstGeom prst="rect">
             <a:avLst/>
@@ -29269,6 +29981,9 @@
               <a:lnSpc>
                 <a:spcPts val="1425"/>
               </a:lnSpc>
+              <a:spcAft>
+                <a:spcPts val="115"/>
+              </a:spcAft>
               <a:buNone/>
             </a:pPr>
             <a:r>
@@ -29314,17 +30029,11 @@
               <a:lnSpc>
                 <a:spcPts val="1425"/>
               </a:lnSpc>
+              <a:spcAft>
+                <a:spcPts val="115"/>
+              </a:spcAft>
               <a:buNone/>
             </a:pPr>
-            <a:br>
-              <a:rPr lang="en-US" b="0" dirty="0">
-                <a:solidFill>
-                  <a:srgbClr val="000000"/>
-                </a:solidFill>
-                <a:effectLst/>
-                <a:latin typeface="Consolas" panose="020B0609020204030204" pitchFamily="49" charset="0"/>
-              </a:rPr>
-            </a:br>
             <a:br>
               <a:rPr lang="en-US" b="0" dirty="0">
                 <a:solidFill>
@@ -29347,6 +30056,9 @@
               <a:lnSpc>
                 <a:spcPts val="1425"/>
               </a:lnSpc>
+              <a:spcAft>
+                <a:spcPts val="115"/>
+              </a:spcAft>
               <a:buNone/>
             </a:pPr>
             <a:r>
@@ -29415,6 +30127,9 @@
               <a:lnSpc>
                 <a:spcPts val="1425"/>
               </a:lnSpc>
+              <a:spcAft>
+                <a:spcPts val="115"/>
+              </a:spcAft>
               <a:buNone/>
             </a:pPr>
             <a:r>
@@ -29450,6 +30165,9 @@
               <a:lnSpc>
                 <a:spcPts val="1425"/>
               </a:lnSpc>
+              <a:spcAft>
+                <a:spcPts val="115"/>
+              </a:spcAft>
               <a:buNone/>
             </a:pPr>
             <a:r>
@@ -29608,6 +30326,9 @@
               <a:lnSpc>
                 <a:spcPts val="1425"/>
               </a:lnSpc>
+              <a:spcAft>
+                <a:spcPts val="115"/>
+              </a:spcAft>
               <a:buNone/>
             </a:pPr>
             <a:r>
@@ -29706,6 +30427,9 @@
               <a:lnSpc>
                 <a:spcPts val="1425"/>
               </a:lnSpc>
+              <a:spcAft>
+                <a:spcPts val="115"/>
+              </a:spcAft>
               <a:buNone/>
             </a:pPr>
             <a:r>
@@ -29804,6 +30528,9 @@
               <a:lnSpc>
                 <a:spcPts val="1425"/>
               </a:lnSpc>
+              <a:spcAft>
+                <a:spcPts val="115"/>
+              </a:spcAft>
               <a:buNone/>
             </a:pPr>
             <a:r>
@@ -29893,7 +30620,7 @@
 </p:sld>
 </file>
 
-<file path=ppt/slides/slide23.xml><?xml version="1.0" encoding="utf-8"?>
+<file path=ppt/slides/slide24.xml><?xml version="1.0" encoding="utf-8"?>
 <p:sld xmlns:a="http://schemas.openxmlformats.org/drawingml/2006/main" xmlns:r="http://schemas.openxmlformats.org/officeDocument/2006/relationships" xmlns:p="http://schemas.openxmlformats.org/presentationml/2006/main">
   <p:cSld>
     <p:spTree>
@@ -29972,7 +30699,7 @@
           <a:p>
             <a:fld id="{AD622D1A-DF83-41A8-85FF-04D90BF831D3}" type="datetime3">
               <a:rPr lang="en-US" smtClean="0"/>
-              <a:t>18 June 2026</a:t>
+              <a:t>23 June 2026</a:t>
             </a:fld>
             <a:endParaRPr lang="en-US"/>
           </a:p>
@@ -30002,7 +30729,7 @@
             <a:fld id="{64E5BE4B-2FBF-4174-9E62-85FAD1CB43A6}" type="slidenum">
               <a:rPr lang="en-US" smtClean="0"/>
               <a:pPr/>
-              <a:t>23</a:t>
+              <a:t>24</a:t>
             </a:fld>
             <a:endParaRPr lang="en-US"/>
           </a:p>
@@ -31257,7 +31984,7 @@
 </p:sld>
 </file>
 
-<file path=ppt/slides/slide24.xml><?xml version="1.0" encoding="utf-8"?>
+<file path=ppt/slides/slide25.xml><?xml version="1.0" encoding="utf-8"?>
 <p:sld xmlns:a="http://schemas.openxmlformats.org/drawingml/2006/main" xmlns:r="http://schemas.openxmlformats.org/officeDocument/2006/relationships" xmlns:p="http://schemas.openxmlformats.org/presentationml/2006/main">
   <p:cSld>
     <p:spTree>
@@ -31356,7 +32083,7 @@
           <a:p>
             <a:fld id="{334F72C3-CDF3-44A8-B602-1649B1728485}" type="datetime3">
               <a:rPr lang="en-US" smtClean="0"/>
-              <a:t>18 June 2026</a:t>
+              <a:t>23 June 2026</a:t>
             </a:fld>
             <a:endParaRPr lang="en-US"/>
           </a:p>
@@ -31386,7 +32113,7 @@
             <a:fld id="{64E5BE4B-2FBF-4174-9E62-85FAD1CB43A6}" type="slidenum">
               <a:rPr lang="en-US" smtClean="0"/>
               <a:pPr/>
-              <a:t>24</a:t>
+              <a:t>25</a:t>
             </a:fld>
             <a:endParaRPr lang="en-US"/>
           </a:p>
@@ -31405,7 +32132,7 @@
 </p:sld>
 </file>
 
-<file path=ppt/slides/slide25.xml><?xml version="1.0" encoding="utf-8"?>
+<file path=ppt/slides/slide26.xml><?xml version="1.0" encoding="utf-8"?>
 <p:sld xmlns:a="http://schemas.openxmlformats.org/drawingml/2006/main" xmlns:r="http://schemas.openxmlformats.org/officeDocument/2006/relationships" xmlns:p="http://schemas.openxmlformats.org/presentationml/2006/main">
   <p:cSld>
     <p:spTree>
@@ -31480,7 +32207,7 @@
           <a:p>
             <a:fld id="{AD622D1A-DF83-41A8-85FF-04D90BF831D3}" type="datetime3">
               <a:rPr lang="en-US" smtClean="0"/>
-              <a:t>18 June 2026</a:t>
+              <a:t>23 June 2026</a:t>
             </a:fld>
             <a:endParaRPr lang="en-US"/>
           </a:p>
@@ -31510,7 +32237,7 @@
             <a:fld id="{64E5BE4B-2FBF-4174-9E62-85FAD1CB43A6}" type="slidenum">
               <a:rPr lang="en-US" smtClean="0"/>
               <a:pPr/>
-              <a:t>25</a:t>
+              <a:t>26</a:t>
             </a:fld>
             <a:endParaRPr lang="en-US"/>
           </a:p>
@@ -31625,7 +32352,7 @@
           <a:p>
             <a:fld id="{AD622D1A-DF83-41A8-85FF-04D90BF831D3}" type="datetime3">
               <a:rPr lang="en-US" smtClean="0"/>
-              <a:t>18 June 2026</a:t>
+              <a:t>23 June 2026</a:t>
             </a:fld>
             <a:endParaRPr lang="en-US"/>
           </a:p>
@@ -31812,7 +32539,7 @@
           <a:p>
             <a:fld id="{AD622D1A-DF83-41A8-85FF-04D90BF831D3}" type="datetime3">
               <a:rPr lang="en-US" smtClean="0"/>
-              <a:t>18 June 2026</a:t>
+              <a:t>23 June 2026</a:t>
             </a:fld>
             <a:endParaRPr lang="en-US"/>
           </a:p>
@@ -31905,6 +32632,178 @@
   <p:clrMapOvr>
     <a:masterClrMapping/>
   </p:clrMapOvr>
+  <p:timing>
+    <p:tnLst>
+      <p:par>
+        <p:cTn id="1" dur="indefinite" restart="never" nodeType="tmRoot">
+          <p:childTnLst>
+            <p:seq concurrent="1" nextAc="seek">
+              <p:cTn id="2" dur="indefinite" nodeType="mainSeq">
+                <p:childTnLst>
+                  <p:par>
+                    <p:cTn id="3" fill="hold">
+                      <p:stCondLst>
+                        <p:cond delay="indefinite"/>
+                      </p:stCondLst>
+                      <p:childTnLst>
+                        <p:par>
+                          <p:cTn id="4" fill="hold">
+                            <p:stCondLst>
+                              <p:cond delay="0"/>
+                            </p:stCondLst>
+                            <p:childTnLst>
+                              <p:par>
+                                <p:cTn id="5" presetID="1" presetClass="entr" presetSubtype="0" fill="hold" nodeType="clickEffect">
+                                  <p:stCondLst>
+                                    <p:cond delay="0"/>
+                                  </p:stCondLst>
+                                  <p:childTnLst>
+                                    <p:set>
+                                      <p:cBhvr>
+                                        <p:cTn id="6" dur="1" fill="hold">
+                                          <p:stCondLst>
+                                            <p:cond delay="0"/>
+                                          </p:stCondLst>
+                                        </p:cTn>
+                                        <p:tgtEl>
+                                          <p:spTgt spid="3">
+                                            <p:txEl>
+                                              <p:pRg st="3" end="3"/>
+                                            </p:txEl>
+                                          </p:spTgt>
+                                        </p:tgtEl>
+                                        <p:attrNameLst>
+                                          <p:attrName>style.visibility</p:attrName>
+                                        </p:attrNameLst>
+                                      </p:cBhvr>
+                                      <p:to>
+                                        <p:strVal val="visible"/>
+                                      </p:to>
+                                    </p:set>
+                                  </p:childTnLst>
+                                </p:cTn>
+                              </p:par>
+                              <p:par>
+                                <p:cTn id="7" presetID="1" presetClass="entr" presetSubtype="0" fill="hold" nodeType="withEffect">
+                                  <p:stCondLst>
+                                    <p:cond delay="0"/>
+                                  </p:stCondLst>
+                                  <p:childTnLst>
+                                    <p:set>
+                                      <p:cBhvr>
+                                        <p:cTn id="8" dur="1" fill="hold">
+                                          <p:stCondLst>
+                                            <p:cond delay="0"/>
+                                          </p:stCondLst>
+                                        </p:cTn>
+                                        <p:tgtEl>
+                                          <p:spTgt spid="3">
+                                            <p:txEl>
+                                              <p:pRg st="4" end="4"/>
+                                            </p:txEl>
+                                          </p:spTgt>
+                                        </p:tgtEl>
+                                        <p:attrNameLst>
+                                          <p:attrName>style.visibility</p:attrName>
+                                        </p:attrNameLst>
+                                      </p:cBhvr>
+                                      <p:to>
+                                        <p:strVal val="visible"/>
+                                      </p:to>
+                                    </p:set>
+                                  </p:childTnLst>
+                                </p:cTn>
+                              </p:par>
+                              <p:par>
+                                <p:cTn id="9" presetID="1" presetClass="entr" presetSubtype="0" fill="hold" nodeType="withEffect">
+                                  <p:stCondLst>
+                                    <p:cond delay="0"/>
+                                  </p:stCondLst>
+                                  <p:childTnLst>
+                                    <p:set>
+                                      <p:cBhvr>
+                                        <p:cTn id="10" dur="1" fill="hold">
+                                          <p:stCondLst>
+                                            <p:cond delay="0"/>
+                                          </p:stCondLst>
+                                        </p:cTn>
+                                        <p:tgtEl>
+                                          <p:spTgt spid="3">
+                                            <p:txEl>
+                                              <p:pRg st="5" end="5"/>
+                                            </p:txEl>
+                                          </p:spTgt>
+                                        </p:tgtEl>
+                                        <p:attrNameLst>
+                                          <p:attrName>style.visibility</p:attrName>
+                                        </p:attrNameLst>
+                                      </p:cBhvr>
+                                      <p:to>
+                                        <p:strVal val="visible"/>
+                                      </p:to>
+                                    </p:set>
+                                  </p:childTnLst>
+                                </p:cTn>
+                              </p:par>
+                              <p:par>
+                                <p:cTn id="11" presetID="1" presetClass="entr" presetSubtype="0" fill="hold" nodeType="withEffect">
+                                  <p:stCondLst>
+                                    <p:cond delay="0"/>
+                                  </p:stCondLst>
+                                  <p:childTnLst>
+                                    <p:set>
+                                      <p:cBhvr>
+                                        <p:cTn id="12" dur="1" fill="hold">
+                                          <p:stCondLst>
+                                            <p:cond delay="0"/>
+                                          </p:stCondLst>
+                                        </p:cTn>
+                                        <p:tgtEl>
+                                          <p:spTgt spid="3">
+                                            <p:txEl>
+                                              <p:pRg st="6" end="6"/>
+                                            </p:txEl>
+                                          </p:spTgt>
+                                        </p:tgtEl>
+                                        <p:attrNameLst>
+                                          <p:attrName>style.visibility</p:attrName>
+                                        </p:attrNameLst>
+                                      </p:cBhvr>
+                                      <p:to>
+                                        <p:strVal val="visible"/>
+                                      </p:to>
+                                    </p:set>
+                                  </p:childTnLst>
+                                </p:cTn>
+                              </p:par>
+                            </p:childTnLst>
+                          </p:cTn>
+                        </p:par>
+                      </p:childTnLst>
+                    </p:cTn>
+                  </p:par>
+                </p:childTnLst>
+              </p:cTn>
+              <p:prevCondLst>
+                <p:cond evt="onPrev" delay="0">
+                  <p:tgtEl>
+                    <p:sldTgt/>
+                  </p:tgtEl>
+                </p:cond>
+              </p:prevCondLst>
+              <p:nextCondLst>
+                <p:cond evt="onNext" delay="0">
+                  <p:tgtEl>
+                    <p:sldTgt/>
+                  </p:tgtEl>
+                </p:cond>
+              </p:nextCondLst>
+            </p:seq>
+          </p:childTnLst>
+        </p:cTn>
+      </p:par>
+    </p:tnLst>
+  </p:timing>
 </p:sld>
 </file>
 
@@ -32107,7 +33006,7 @@
             <a:fld id="{AD622D1A-DF83-41A8-85FF-04D90BF831D3}" type="datetime3">
               <a:rPr lang="en-US" smtClean="0"/>
               <a:pPr/>
-              <a:t>18 June 2026</a:t>
+              <a:t>23 June 2026</a:t>
             </a:fld>
             <a:endParaRPr lang="en-US"/>
           </a:p>
@@ -32387,7 +33286,7 @@
           <a:p>
             <a:fld id="{AD622D1A-DF83-41A8-85FF-04D90BF831D3}" type="datetime3">
               <a:rPr lang="en-US" smtClean="0"/>
-              <a:t>18 June 2026</a:t>
+              <a:t>23 June 2026</a:t>
             </a:fld>
             <a:endParaRPr lang="en-US"/>
           </a:p>
@@ -32571,7 +33470,7 @@
           <a:p>
             <a:fld id="{AD622D1A-DF83-41A8-85FF-04D90BF831D3}" type="datetime3">
               <a:rPr lang="en-US" smtClean="0"/>
-              <a:t>18 June 2026</a:t>
+              <a:t>23 June 2026</a:t>
             </a:fld>
             <a:endParaRPr lang="en-US"/>
           </a:p>
@@ -32789,7 +33688,7 @@
           <a:p>
             <a:r>
               <a:rPr lang="en-US" dirty="0"/>
-              <a:t>Tests should be independent, reproducible, and small!!</a:t>
+              <a:t>Tests should be complete, independent, reproducible, and small!!</a:t>
             </a:r>
           </a:p>
         </p:txBody>
@@ -32817,7 +33716,7 @@
           <a:p>
             <a:fld id="{AD622D1A-DF83-41A8-85FF-04D90BF831D3}" type="datetime3">
               <a:rPr lang="en-US" smtClean="0"/>
-              <a:t>18 June 2026</a:t>
+              <a:t>23 June 2026</a:t>
             </a:fld>
             <a:endParaRPr lang="en-US"/>
           </a:p>
@@ -32931,7 +33830,7 @@
           <a:p>
             <a:fld id="{AD622D1A-DF83-41A8-85FF-04D90BF831D3}" type="datetime3">
               <a:rPr lang="en-US" smtClean="0"/>
-              <a:t>18 June 2026</a:t>
+              <a:t>23 June 2026</a:t>
             </a:fld>
             <a:endParaRPr lang="en-US"/>
           </a:p>

</xml_diff>